<commit_message>
Redistribute figures across A1 (厳密) and A2 (応用) papers
A1 (JMLR, theory-focused) now has 4 unique figures:
- fig1_three_approaches (conceptual overview, added to intro)
- fig2_magnetic_laplacian_q (Fiedler eigenvector)
- fig3_hodge_decomposition (Hodge results)
- fig8_alpha_sweep (phase transition analysis)

A2 (clinical/applied) now has 5 unique figures:
- fig6_causal_dag (DirectLiNGAM DAG)
- fig5_hill_radar (Hill's criteria)
- fig4_direction_comparison (method comparison)
- fig7_lingam_vs_spectral (three-condition comparison)
- fig9_ecd_pruning_analysis (ECD pipeline)

Zero overlap between papers. Each paper stands independently.
Removed companion paper cross-references per author request.
Regenerated all docx/pptx outputs.

Co-Authored-By: Tatsuki Onishi <bougtoir@gmail.com>
</commit_message>
<xml_diff>
--- a/spectral-causality-a2-ecd/figures_a2_ecd.pptx
+++ b/spectral-causality-a2-ecd/figures_a2_ecd.pptx
@@ -10,8 +10,6 @@
     <p:sldId id="258" r:id="rId9"/>
     <p:sldId id="259" r:id="rId10"/>
     <p:sldId id="260" r:id="rId11"/>
-    <p:sldId id="261" r:id="rId12"/>
-    <p:sldId id="262" r:id="rId13"/>
   </p:sldIdLst>
   <p:sldSz cx="12191695" cy="6858000" type="screen4x3"/>
   <p:notesSz cx="6858000" cy="9144000"/>
@@ -3328,111 +3326,7 @@
               <a:defRPr sz="2000" b="1"/>
             </a:pPr>
             <a:r>
-              <a:t>Figure 3: Hodge Decomposition of Causal Flows</a:t>
-            </a:r>
-          </a:p>
-        </p:txBody>
-      </p:sp>
-      <p:pic>
-        <p:nvPicPr>
-          <p:cNvPr id="3" name="Picture 2" descr="fig3_hodge_decomposition.png"/>
-          <p:cNvPicPr>
-            <a:picLocks noChangeAspect="1"/>
-          </p:cNvPicPr>
-          <p:nvPr/>
-        </p:nvPicPr>
-        <p:blipFill>
-          <a:blip r:embed="rId2"/>
-          <a:stretch>
-            <a:fillRect/>
-          </a:stretch>
-        </p:blipFill>
-        <p:spPr>
-          <a:xfrm>
-            <a:off x="1828800" y="1097280"/>
-            <a:ext cx="8503920" cy="4754880"/>
-          </a:xfrm>
-          <a:prstGeom prst="rect">
-            <a:avLst/>
-          </a:prstGeom>
-        </p:spPr>
-      </p:pic>
-      <p:sp>
-        <p:nvSpPr>
-          <p:cNvPr id="4" name="TextBox 3"/>
-          <p:cNvSpPr txBox="1"/>
-          <p:nvPr/>
-        </p:nvSpPr>
-        <p:spPr>
-          <a:xfrm>
-            <a:off x="914400" y="6035040"/>
-            <a:ext cx="10332720" cy="640080"/>
-          </a:xfrm>
-          <a:prstGeom prst="rect">
-            <a:avLst/>
-          </a:prstGeom>
-          <a:noFill/>
-        </p:spPr>
-        <p:txBody>
-          <a:bodyPr wrap="none">
-            <a:spAutoFit/>
-          </a:bodyPr>
-          <a:lstStyle/>
-          <a:p>
-            <a:pPr algn="l">
-              <a:defRPr sz="1200" i="1"/>
-            </a:pPr>
-            <a:r>
-              <a:t>Left: gradient (DAG). Middle: curl (feedback). Right: combined.</a:t>
-            </a:r>
-          </a:p>
-        </p:txBody>
-      </p:sp>
-    </p:spTree>
-  </p:cSld>
-  <p:clrMapOvr>
-    <a:masterClrMapping/>
-  </p:clrMapOvr>
-</p:sld>
-</file>
-
-<file path=ppt/slides/slide4.xml><?xml version="1.0" encoding="utf-8"?>
-<p:sld xmlns:a="http://schemas.openxmlformats.org/drawingml/2006/main" xmlns:p="http://schemas.openxmlformats.org/presentationml/2006/main" xmlns:r="http://schemas.openxmlformats.org/officeDocument/2006/relationships">
-  <p:cSld>
-    <p:spTree>
-      <p:nvGrpSpPr>
-        <p:cNvPr id="1" name=""/>
-        <p:cNvGrpSpPr/>
-        <p:nvPr/>
-      </p:nvGrpSpPr>
-      <p:grpSpPr/>
-      <p:sp>
-        <p:nvSpPr>
-          <p:cNvPr id="2" name="TextBox 1"/>
-          <p:cNvSpPr txBox="1"/>
-          <p:nvPr/>
-        </p:nvSpPr>
-        <p:spPr>
-          <a:xfrm>
-            <a:off x="457200" y="182880"/>
-            <a:ext cx="11247120" cy="731520"/>
-          </a:xfrm>
-          <a:prstGeom prst="rect">
-            <a:avLst/>
-          </a:prstGeom>
-          <a:noFill/>
-        </p:spPr>
-        <p:txBody>
-          <a:bodyPr wrap="none">
-            <a:spAutoFit/>
-          </a:bodyPr>
-          <a:lstStyle/>
-          <a:p>
-            <a:pPr algn="l">
-              <a:defRPr sz="2000" b="1"/>
-            </a:pPr>
-            <a:r>
-              <a:t>Figure 4: Three-Method Direction Comparison</a:t>
+              <a:t>Figure 3: Three-Method Direction Comparison</a:t>
             </a:r>
           </a:p>
         </p:txBody>
@@ -3500,7 +3394,7 @@
 </p:sld>
 </file>
 
-<file path=ppt/slides/slide5.xml><?xml version="1.0" encoding="utf-8"?>
+<file path=ppt/slides/slide4.xml><?xml version="1.0" encoding="utf-8"?>
 <p:sld xmlns:a="http://schemas.openxmlformats.org/drawingml/2006/main" xmlns:p="http://schemas.openxmlformats.org/presentationml/2006/main" xmlns:r="http://schemas.openxmlformats.org/officeDocument/2006/relationships">
   <p:cSld>
     <p:spTree>
@@ -3536,7 +3430,7 @@
               <a:defRPr sz="2000" b="1"/>
             </a:pPr>
             <a:r>
-              <a:t>Figure 5: LiNGAM DAG vs. Spectral Causality DCG</a:t>
+              <a:t>Figure 4: LiNGAM DAG vs. Spectral Causality DCG</a:t>
             </a:r>
           </a:p>
         </p:txBody>
@@ -3604,7 +3498,7 @@
 </p:sld>
 </file>
 
-<file path=ppt/slides/slide6.xml><?xml version="1.0" encoding="utf-8"?>
+<file path=ppt/slides/slide5.xml><?xml version="1.0" encoding="utf-8"?>
 <p:sld xmlns:a="http://schemas.openxmlformats.org/drawingml/2006/main" xmlns:p="http://schemas.openxmlformats.org/presentationml/2006/main" xmlns:r="http://schemas.openxmlformats.org/officeDocument/2006/relationships">
   <p:cSld>
     <p:spTree>
@@ -3640,7 +3534,7 @@
               <a:defRPr sz="2000" b="1"/>
             </a:pPr>
             <a:r>
-              <a:t>Figure 6: ECD Ensemble &amp; Pruning Analysis</a:t>
+              <a:t>Figure 5: ECD Ensemble &amp; Pruning Analysis</a:t>
             </a:r>
           </a:p>
         </p:txBody>
@@ -3696,110 +3590,6 @@
             </a:pPr>
             <a:r>
               <a:t>Edge-level feedback rates and bootstrap confidence intervals.</a:t>
-            </a:r>
-          </a:p>
-        </p:txBody>
-      </p:sp>
-    </p:spTree>
-  </p:cSld>
-  <p:clrMapOvr>
-    <a:masterClrMapping/>
-  </p:clrMapOvr>
-</p:sld>
-</file>
-
-<file path=ppt/slides/slide7.xml><?xml version="1.0" encoding="utf-8"?>
-<p:sld xmlns:a="http://schemas.openxmlformats.org/drawingml/2006/main" xmlns:p="http://schemas.openxmlformats.org/presentationml/2006/main" xmlns:r="http://schemas.openxmlformats.org/officeDocument/2006/relationships">
-  <p:cSld>
-    <p:spTree>
-      <p:nvGrpSpPr>
-        <p:cNvPr id="1" name=""/>
-        <p:cNvGrpSpPr/>
-        <p:nvPr/>
-      </p:nvGrpSpPr>
-      <p:grpSpPr/>
-      <p:sp>
-        <p:nvSpPr>
-          <p:cNvPr id="2" name="TextBox 1"/>
-          <p:cNvSpPr txBox="1"/>
-          <p:nvPr/>
-        </p:nvSpPr>
-        <p:spPr>
-          <a:xfrm>
-            <a:off x="457200" y="182880"/>
-            <a:ext cx="11247120" cy="731520"/>
-          </a:xfrm>
-          <a:prstGeom prst="rect">
-            <a:avLst/>
-          </a:prstGeom>
-          <a:noFill/>
-        </p:spPr>
-        <p:txBody>
-          <a:bodyPr wrap="none">
-            <a:spAutoFit/>
-          </a:bodyPr>
-          <a:lstStyle/>
-          <a:p>
-            <a:pPr algn="l">
-              <a:defRPr sz="2000" b="1"/>
-            </a:pPr>
-            <a:r>
-              <a:t>Figure 7: DAG Transition Analysis</a:t>
-            </a:r>
-          </a:p>
-        </p:txBody>
-      </p:sp>
-      <p:pic>
-        <p:nvPicPr>
-          <p:cNvPr id="3" name="Picture 2" descr="fig8_alpha_sweep.png"/>
-          <p:cNvPicPr>
-            <a:picLocks noChangeAspect="1"/>
-          </p:cNvPicPr>
-          <p:nvPr/>
-        </p:nvPicPr>
-        <p:blipFill>
-          <a:blip r:embed="rId2"/>
-          <a:stretch>
-            <a:fillRect/>
-          </a:stretch>
-        </p:blipFill>
-        <p:spPr>
-          <a:xfrm>
-            <a:off x="1828800" y="1097280"/>
-            <a:ext cx="8503920" cy="4754880"/>
-          </a:xfrm>
-          <a:prstGeom prst="rect">
-            <a:avLst/>
-          </a:prstGeom>
-        </p:spPr>
-      </p:pic>
-      <p:sp>
-        <p:nvSpPr>
-          <p:cNvPr id="4" name="TextBox 3"/>
-          <p:cNvSpPr txBox="1"/>
-          <p:nvPr/>
-        </p:nvSpPr>
-        <p:spPr>
-          <a:xfrm>
-            <a:off x="914400" y="6035040"/>
-            <a:ext cx="10332720" cy="640080"/>
-          </a:xfrm>
-          <a:prstGeom prst="rect">
-            <a:avLst/>
-          </a:prstGeom>
-          <a:noFill/>
-        </p:spPr>
-        <p:txBody>
-          <a:bodyPr wrap="none">
-            <a:spAutoFit/>
-          </a:bodyPr>
-          <a:lstStyle/>
-          <a:p>
-            <a:pPr algn="l">
-              <a:defRPr sz="1200" i="1"/>
-            </a:pPr>
-            <a:r>
-              <a:t>(A) r_gradient vs alpha. (B) Edge count and LiNGAM agreement.</a:t>
             </a:r>
           </a:p>
         </p:txBody>

</xml_diff>

<commit_message>
Add 6 new figures to strengthen A1/A2 paper identities
A1 (厳密/JMLR) +3 figures:
- fig_dpi_architecture.png: DPI 3-component block diagram (§4.2)
- fig_cci_complex_plane.png: CCI variable pairs in complex plane (§4.4)
- fig_pflip_ucurve.png: Knowledge quality phase transition U-curve (§8.2)

A2 (応用/Clinical) +3 figures:
- fig_ecd_pipeline.png: 4-step ECD deployment pipeline (§3.5)
- fig_interventionability.png: Hodge φ vs clinical ι scatter (§4.2)
- fig_feedback_network.png: 5-node feedback network with rates (§8.2)

All figures generated via matplotlib (generate_new_figures.py).
Manuscripts (LaTeX/markdown EN+JA), docx generators, pptx updated.
All docx/pptx outputs regenerated with new figures inline.

Co-Authored-By: Tatsuki Onishi <bougtoir@gmail.com>
</commit_message>
<xml_diff>
--- a/spectral-causality-a2-ecd/figures_a2_ecd.pptx
+++ b/spectral-causality-a2-ecd/figures_a2_ecd.pptx
@@ -10,6 +10,9 @@
     <p:sldId id="258" r:id="rId9"/>
     <p:sldId id="259" r:id="rId10"/>
     <p:sldId id="260" r:id="rId11"/>
+    <p:sldId id="261" r:id="rId12"/>
+    <p:sldId id="262" r:id="rId13"/>
+    <p:sldId id="263" r:id="rId14"/>
   </p:sldIdLst>
   <p:sldSz cx="12191695" cy="6858000" type="screen4x3"/>
   <p:notesSz cx="6858000" cy="9144000"/>
@@ -3590,6 +3593,318 @@
             </a:pPr>
             <a:r>
               <a:t>Edge-level feedback rates and bootstrap confidence intervals.</a:t>
+            </a:r>
+          </a:p>
+        </p:txBody>
+      </p:sp>
+    </p:spTree>
+  </p:cSld>
+  <p:clrMapOvr>
+    <a:masterClrMapping/>
+  </p:clrMapOvr>
+</p:sld>
+</file>
+
+<file path=ppt/slides/slide6.xml><?xml version="1.0" encoding="utf-8"?>
+<p:sld xmlns:a="http://schemas.openxmlformats.org/drawingml/2006/main" xmlns:p="http://schemas.openxmlformats.org/presentationml/2006/main" xmlns:r="http://schemas.openxmlformats.org/officeDocument/2006/relationships">
+  <p:cSld>
+    <p:spTree>
+      <p:nvGrpSpPr>
+        <p:cNvPr id="1" name=""/>
+        <p:cNvGrpSpPr/>
+        <p:nvPr/>
+      </p:nvGrpSpPr>
+      <p:grpSpPr/>
+      <p:sp>
+        <p:nvSpPr>
+          <p:cNvPr id="2" name="TextBox 1"/>
+          <p:cNvSpPr txBox="1"/>
+          <p:nvPr/>
+        </p:nvSpPr>
+        <p:spPr>
+          <a:xfrm>
+            <a:off x="457200" y="182880"/>
+            <a:ext cx="11247120" cy="731520"/>
+          </a:xfrm>
+          <a:prstGeom prst="rect">
+            <a:avLst/>
+          </a:prstGeom>
+          <a:noFill/>
+        </p:spPr>
+        <p:txBody>
+          <a:bodyPr wrap="none">
+            <a:spAutoFit/>
+          </a:bodyPr>
+          <a:lstStyle/>
+          <a:p>
+            <a:pPr algn="l">
+              <a:defRPr sz="2000" b="1"/>
+            </a:pPr>
+            <a:r>
+              <a:t>Figure 6: ECD Deployment Pipeline</a:t>
+            </a:r>
+          </a:p>
+        </p:txBody>
+      </p:sp>
+      <p:pic>
+        <p:nvPicPr>
+          <p:cNvPr id="3" name="Picture 2" descr="fig_ecd_pipeline.png"/>
+          <p:cNvPicPr>
+            <a:picLocks noChangeAspect="1"/>
+          </p:cNvPicPr>
+          <p:nvPr/>
+        </p:nvPicPr>
+        <p:blipFill>
+          <a:blip r:embed="rId2"/>
+          <a:stretch>
+            <a:fillRect/>
+          </a:stretch>
+        </p:blipFill>
+        <p:spPr>
+          <a:xfrm>
+            <a:off x="1828800" y="1097280"/>
+            <a:ext cx="8503920" cy="4754880"/>
+          </a:xfrm>
+          <a:prstGeom prst="rect">
+            <a:avLst/>
+          </a:prstGeom>
+        </p:spPr>
+      </p:pic>
+      <p:sp>
+        <p:nvSpPr>
+          <p:cNvPr id="4" name="TextBox 3"/>
+          <p:cNvSpPr txBox="1"/>
+          <p:nvPr/>
+        </p:nvSpPr>
+        <p:spPr>
+          <a:xfrm>
+            <a:off x="914400" y="6035040"/>
+            <a:ext cx="10332720" cy="640080"/>
+          </a:xfrm>
+          <a:prstGeom prst="rect">
+            <a:avLst/>
+          </a:prstGeom>
+          <a:noFill/>
+        </p:spPr>
+        <p:txBody>
+          <a:bodyPr wrap="none">
+            <a:spAutoFit/>
+          </a:bodyPr>
+          <a:lstStyle/>
+          <a:p>
+            <a:pPr algn="l">
+              <a:defRPr sz="1200" i="1"/>
+            </a:pPr>
+            <a:r>
+              <a:t>Four-step pipeline: LiNGAM bootstrap → DPI spectral analysis → Hodge decomposition → Interventionability scoring.</a:t>
+            </a:r>
+          </a:p>
+        </p:txBody>
+      </p:sp>
+    </p:spTree>
+  </p:cSld>
+  <p:clrMapOvr>
+    <a:masterClrMapping/>
+  </p:clrMapOvr>
+</p:sld>
+</file>
+
+<file path=ppt/slides/slide7.xml><?xml version="1.0" encoding="utf-8"?>
+<p:sld xmlns:a="http://schemas.openxmlformats.org/drawingml/2006/main" xmlns:p="http://schemas.openxmlformats.org/presentationml/2006/main" xmlns:r="http://schemas.openxmlformats.org/officeDocument/2006/relationships">
+  <p:cSld>
+    <p:spTree>
+      <p:nvGrpSpPr>
+        <p:cNvPr id="1" name=""/>
+        <p:cNvGrpSpPr/>
+        <p:nvPr/>
+      </p:nvGrpSpPr>
+      <p:grpSpPr/>
+      <p:sp>
+        <p:nvSpPr>
+          <p:cNvPr id="2" name="TextBox 1"/>
+          <p:cNvSpPr txBox="1"/>
+          <p:nvPr/>
+        </p:nvSpPr>
+        <p:spPr>
+          <a:xfrm>
+            <a:off x="457200" y="182880"/>
+            <a:ext cx="11247120" cy="731520"/>
+          </a:xfrm>
+          <a:prstGeom prst="rect">
+            <a:avLst/>
+          </a:prstGeom>
+          <a:noFill/>
+        </p:spPr>
+        <p:txBody>
+          <a:bodyPr wrap="none">
+            <a:spAutoFit/>
+          </a:bodyPr>
+          <a:lstStyle/>
+          <a:p>
+            <a:pPr algn="l">
+              <a:defRPr sz="2000" b="1"/>
+            </a:pPr>
+            <a:r>
+              <a:t>Figure 7: Causal Potential vs. Interventionability</a:t>
+            </a:r>
+          </a:p>
+        </p:txBody>
+      </p:sp>
+      <p:pic>
+        <p:nvPicPr>
+          <p:cNvPr id="3" name="Picture 2" descr="fig_interventionability.png"/>
+          <p:cNvPicPr>
+            <a:picLocks noChangeAspect="1"/>
+          </p:cNvPicPr>
+          <p:nvPr/>
+        </p:nvPicPr>
+        <p:blipFill>
+          <a:blip r:embed="rId2"/>
+          <a:stretch>
+            <a:fillRect/>
+          </a:stretch>
+        </p:blipFill>
+        <p:spPr>
+          <a:xfrm>
+            <a:off x="1828800" y="1097280"/>
+            <a:ext cx="8503920" cy="4754880"/>
+          </a:xfrm>
+          <a:prstGeom prst="rect">
+            <a:avLst/>
+          </a:prstGeom>
+        </p:spPr>
+      </p:pic>
+      <p:sp>
+        <p:nvSpPr>
+          <p:cNvPr id="4" name="TextBox 3"/>
+          <p:cNvSpPr txBox="1"/>
+          <p:nvPr/>
+        </p:nvSpPr>
+        <p:spPr>
+          <a:xfrm>
+            <a:off x="914400" y="6035040"/>
+            <a:ext cx="10332720" cy="640080"/>
+          </a:xfrm>
+          <a:prstGeom prst="rect">
+            <a:avLst/>
+          </a:prstGeom>
+          <a:noFill/>
+        </p:spPr>
+        <p:txBody>
+          <a:bodyPr wrap="none">
+            <a:spAutoFit/>
+          </a:bodyPr>
+          <a:lstStyle/>
+          <a:p>
+            <a:pPr algn="l">
+              <a:defRPr sz="1200" i="1"/>
+            </a:pPr>
+            <a:r>
+              <a:t>Hodge potential φ vs. clinical interventionability ι. Inverse relationship demonstrates mathematical-clinical correspondence.</a:t>
+            </a:r>
+          </a:p>
+        </p:txBody>
+      </p:sp>
+    </p:spTree>
+  </p:cSld>
+  <p:clrMapOvr>
+    <a:masterClrMapping/>
+  </p:clrMapOvr>
+</p:sld>
+</file>
+
+<file path=ppt/slides/slide8.xml><?xml version="1.0" encoding="utf-8"?>
+<p:sld xmlns:a="http://schemas.openxmlformats.org/drawingml/2006/main" xmlns:p="http://schemas.openxmlformats.org/presentationml/2006/main" xmlns:r="http://schemas.openxmlformats.org/officeDocument/2006/relationships">
+  <p:cSld>
+    <p:spTree>
+      <p:nvGrpSpPr>
+        <p:cNvPr id="1" name=""/>
+        <p:cNvGrpSpPr/>
+        <p:nvPr/>
+      </p:nvGrpSpPr>
+      <p:grpSpPr/>
+      <p:sp>
+        <p:nvSpPr>
+          <p:cNvPr id="2" name="TextBox 1"/>
+          <p:cNvSpPr txBox="1"/>
+          <p:nvPr/>
+        </p:nvSpPr>
+        <p:spPr>
+          <a:xfrm>
+            <a:off x="457200" y="182880"/>
+            <a:ext cx="11247120" cy="731520"/>
+          </a:xfrm>
+          <a:prstGeom prst="rect">
+            <a:avLst/>
+          </a:prstGeom>
+          <a:noFill/>
+        </p:spPr>
+        <p:txBody>
+          <a:bodyPr wrap="none">
+            <a:spAutoFit/>
+          </a:bodyPr>
+          <a:lstStyle/>
+          <a:p>
+            <a:pPr algn="l">
+              <a:defRPr sz="2000" b="1"/>
+            </a:pPr>
+            <a:r>
+              <a:t>Figure 8: Clinical Feedback Network</a:t>
+            </a:r>
+          </a:p>
+        </p:txBody>
+      </p:sp>
+      <p:pic>
+        <p:nvPicPr>
+          <p:cNvPr id="3" name="Picture 2" descr="fig_feedback_network.png"/>
+          <p:cNvPicPr>
+            <a:picLocks noChangeAspect="1"/>
+          </p:cNvPicPr>
+          <p:nvPr/>
+        </p:nvPicPr>
+        <p:blipFill>
+          <a:blip r:embed="rId2"/>
+          <a:stretch>
+            <a:fillRect/>
+          </a:stretch>
+        </p:blipFill>
+        <p:spPr>
+          <a:xfrm>
+            <a:off x="1828800" y="1097280"/>
+            <a:ext cx="8503920" cy="4754880"/>
+          </a:xfrm>
+          <a:prstGeom prst="rect">
+            <a:avLst/>
+          </a:prstGeom>
+        </p:spPr>
+      </p:pic>
+      <p:sp>
+        <p:nvSpPr>
+          <p:cNvPr id="4" name="TextBox 3"/>
+          <p:cNvSpPr txBox="1"/>
+          <p:nvPr/>
+        </p:nvSpPr>
+        <p:spPr>
+          <a:xfrm>
+            <a:off x="914400" y="6035040"/>
+            <a:ext cx="10332720" cy="640080"/>
+          </a:xfrm>
+          <a:prstGeom prst="rect">
+            <a:avLst/>
+          </a:prstGeom>
+          <a:noFill/>
+        </p:spPr>
+        <p:txBody>
+          <a:bodyPr wrap="none">
+            <a:spAutoFit/>
+          </a:bodyPr>
+          <a:lstStyle/>
+          <a:p>
+            <a:pPr algn="l">
+              <a:defRPr sz="1200" i="1"/>
+            </a:pPr>
+            <a:r>
+              <a:t>Edge colors: green = unidirectional (&lt;10%), orange = weak feedback (10–50%), red = strong feedback (&gt;50%). MaxHR ↔ STDep: 73%.</a:t>
             </a:r>
           </a:p>
         </p:txBody>

</xml_diff>